<commit_message>
feat(workflow): add target graph and control-plane contracts
Implement workflow_graph validation and rendering, host capability probing/bootstrap evidence, agent-team runtime evidence checks, managed recovery reports, deeper clarification gates, and refreshed plugin dist/test fixtures. Host-global bootstrap is plan-only; project-local bootstrap remains the only automatic path.
</commit_message>
<xml_diff>
--- a/docs/workflowprogram-flow-slides/workflowprogram_flow_overview.pptx
+++ b/docs/workflowprogram-flow-slides/workflowprogram_flow_overview.pptx
@@ -8188,8 +8188,8 @@
         </p:nvSpPr>
         <p:spPr>
           <a:xfrm>
-            <a:off x="457200" y="256032"/>
-            <a:ext cx="7955280" cy="411480"/>
+            <a:off x="457200" y="255905"/>
+            <a:ext cx="9361805" cy="411480"/>
           </a:xfrm>
           <a:prstGeom prst="rect">
             <a:avLst/>
@@ -9155,7 +9155,7 @@
         </p:nvSpPr>
         <p:spPr>
           <a:xfrm>
-            <a:off x="941832" y="4846320"/>
+            <a:off x="941832" y="4215130"/>
             <a:ext cx="1042416" cy="292608"/>
           </a:xfrm>
           <a:prstGeom prst="rect">
@@ -9194,7 +9194,7 @@
           <p:nvPr/>
         </p:nvGraphicFramePr>
         <p:xfrm>
-          <a:off x="868680" y="5257800"/>
+          <a:off x="868680" y="4626610"/>
           <a:ext cx="10789920" cy="1243584"/>
         </p:xfrm>
         <a:graphic>

</xml_diff>